<commit_message>
docs(orgcomp): cite FedRAMP's actual PAIN-rating SLA model in Books 03/06/07
"SLA class keyed to KEV/exposure" was gesturing at CISA BOD 26-04 without
citing what FedRAMP actually specifies. FedRAMP's Vulnerability Detection
and Response ruleset (VDR-TFR-PVR) names a concrete model — remediation
timeframes by Potential Agency Impact (PAIN) rating crossed with
exploitability and internet-reachability, 4 to 192 days depending on the
cell. Replace the vague "four-variable model" phrasing with the actual
table in all three CSP books' Engine 2/3 sections and References, and
fix two more stale "OCI and VMware" cross-references in Book 06 that
should have been updated when Book 07 shipped.

Co-Authored-By: Claude Sonnet 5 <noreply@anthropic.com>
</commit_message>
<xml_diff>
--- a/docs/customer-documents/orgcomp-series/Vol_VII_Book_03_OrgComp_Azure_Control_Compliance_Automation.pptx
+++ b/docs/customer-documents/orgcomp-series/Vol_VII_Book_03_OrgComp_Azure_Control_Compliance_Automation.pptx
@@ -1042,7 +1042,7 @@
           <a:p/>
           <a:p>
             <a:r>
-              <a:t>Vendor sources: host repo: docs/customer-documents/federal-aan-series/aan-compliance-spine.yml</a:t>
+              <a:t>Vendor sources: host repo: docs/customer-documents/orgcomp-series/orgcomp-compliance-spine.yml</a:t>
             </a:r>
           </a:p>
         </p:txBody>
@@ -4877,7 +4877,7 @@
                 </a:solidFill>
                 <a:latin typeface="Arial"/>
               </a:rPr>
-              <a:t>Date Code: 2026-07-12 15:00 ET</a:t>
+              <a:t>Date Code: 2026-07-28 08:45 ET</a:t>
             </a:r>
           </a:p>
         </p:txBody>
@@ -5065,7 +5065,7 @@
                 </a:solidFill>
                 <a:latin typeface="Arial"/>
               </a:rPr>
-              <a:t>Azure Federal Control Compliance Automation · Date Code: 2026-07-12 15:00 ET</a:t>
+              <a:t>Azure Federal Control Compliance Automation · Date Code: 2026-07-28 08:45 ET</a:t>
             </a:r>
           </a:p>
         </p:txBody>
@@ -5288,7 +5288,7 @@
                 </a:solidFill>
                 <a:latin typeface="Arial"/>
               </a:rPr>
-              <a:t>Azure Federal Control Compliance Automation · Date Code: 2026-07-12 15:00 ET</a:t>
+              <a:t>Azure Federal Control Compliance Automation · Date Code: 2026-07-28 08:45 ET</a:t>
             </a:r>
           </a:p>
         </p:txBody>
@@ -6195,7 +6195,7 @@
                 </a:solidFill>
                 <a:latin typeface="Arial"/>
               </a:rPr>
-              <a:t>Azure Federal Control Compliance Automation · Date Code: 2026-07-12 15:00 ET</a:t>
+              <a:t>Azure Federal Control Compliance Automation · Date Code: 2026-07-28 08:45 ET</a:t>
             </a:r>
           </a:p>
         </p:txBody>
@@ -7189,7 +7189,7 @@
                 </a:solidFill>
                 <a:latin typeface="Arial"/>
               </a:rPr>
-              <a:t>Azure Federal Control Compliance Automation · Date Code: 2026-07-12 15:00 ET</a:t>
+              <a:t>Azure Federal Control Compliance Automation · Date Code: 2026-07-28 08:45 ET</a:t>
             </a:r>
           </a:p>
         </p:txBody>
@@ -8183,7 +8183,7 @@
                 </a:solidFill>
                 <a:latin typeface="Arial"/>
               </a:rPr>
-              <a:t>Azure Federal Control Compliance Automation · Date Code: 2026-07-12 15:00 ET</a:t>
+              <a:t>Azure Federal Control Compliance Automation · Date Code: 2026-07-28 08:45 ET</a:t>
             </a:r>
           </a:p>
         </p:txBody>
@@ -9177,7 +9177,7 @@
                 </a:solidFill>
                 <a:latin typeface="Arial"/>
               </a:rPr>
-              <a:t>Azure Federal Control Compliance Automation · Date Code: 2026-07-12 15:00 ET</a:t>
+              <a:t>Azure Federal Control Compliance Automation · Date Code: 2026-07-28 08:45 ET</a:t>
             </a:r>
           </a:p>
         </p:txBody>
@@ -10171,7 +10171,7 @@
                 </a:solidFill>
                 <a:latin typeface="Arial"/>
               </a:rPr>
-              <a:t>Azure Federal Control Compliance Automation · Date Code: 2026-07-12 15:00 ET</a:t>
+              <a:t>Azure Federal Control Compliance Automation · Date Code: 2026-07-28 08:45 ET</a:t>
             </a:r>
           </a:p>
         </p:txBody>
@@ -10693,7 +10693,7 @@
                 </a:solidFill>
                 <a:latin typeface="Arial"/>
               </a:rPr>
-              <a:t>Azure Federal Control Compliance Automation · Date Code: 2026-07-12 15:00 ET</a:t>
+              <a:t>Azure Federal Control Compliance Automation · Date Code: 2026-07-28 08:45 ET</a:t>
             </a:r>
           </a:p>
         </p:txBody>

</xml_diff>

<commit_message>
docs(orgcomp): cite FedRAMP's actual PAIN-rating SLA model in Books 03/06/07 (#1383)
"SLA class keyed to KEV/exposure" was gesturing at CISA BOD 26-04 without
citing what FedRAMP actually specifies. FedRAMP's Vulnerability Detection
and Response ruleset (VDR-TFR-PVR) names a concrete model — remediation
timeframes by Potential Agency Impact (PAIN) rating crossed with
exploitability and internet-reachability, 4 to 192 days depending on the
cell. Replace the vague "four-variable model" phrasing with the actual
table in all three CSP books' Engine 2/3 sections and References, and
fix two more stale "OCI and VMware" cross-references in Book 06 that
should have been updated when Book 07 shipped.

Co-authored-by: Claude Sonnet 5 <noreply@anthropic.com>
</commit_message>
<xml_diff>
--- a/docs/customer-documents/orgcomp-series/Vol_VII_Book_03_OrgComp_Azure_Control_Compliance_Automation.pptx
+++ b/docs/customer-documents/orgcomp-series/Vol_VII_Book_03_OrgComp_Azure_Control_Compliance_Automation.pptx
@@ -1042,7 +1042,7 @@
           <a:p/>
           <a:p>
             <a:r>
-              <a:t>Vendor sources: host repo: docs/customer-documents/federal-aan-series/aan-compliance-spine.yml</a:t>
+              <a:t>Vendor sources: host repo: docs/customer-documents/orgcomp-series/orgcomp-compliance-spine.yml</a:t>
             </a:r>
           </a:p>
         </p:txBody>
@@ -4877,7 +4877,7 @@
                 </a:solidFill>
                 <a:latin typeface="Arial"/>
               </a:rPr>
-              <a:t>Date Code: 2026-07-12 15:00 ET</a:t>
+              <a:t>Date Code: 2026-07-28 08:45 ET</a:t>
             </a:r>
           </a:p>
         </p:txBody>
@@ -5065,7 +5065,7 @@
                 </a:solidFill>
                 <a:latin typeface="Arial"/>
               </a:rPr>
-              <a:t>Azure Federal Control Compliance Automation · Date Code: 2026-07-12 15:00 ET</a:t>
+              <a:t>Azure Federal Control Compliance Automation · Date Code: 2026-07-28 08:45 ET</a:t>
             </a:r>
           </a:p>
         </p:txBody>
@@ -5288,7 +5288,7 @@
                 </a:solidFill>
                 <a:latin typeface="Arial"/>
               </a:rPr>
-              <a:t>Azure Federal Control Compliance Automation · Date Code: 2026-07-12 15:00 ET</a:t>
+              <a:t>Azure Federal Control Compliance Automation · Date Code: 2026-07-28 08:45 ET</a:t>
             </a:r>
           </a:p>
         </p:txBody>
@@ -6195,7 +6195,7 @@
                 </a:solidFill>
                 <a:latin typeface="Arial"/>
               </a:rPr>
-              <a:t>Azure Federal Control Compliance Automation · Date Code: 2026-07-12 15:00 ET</a:t>
+              <a:t>Azure Federal Control Compliance Automation · Date Code: 2026-07-28 08:45 ET</a:t>
             </a:r>
           </a:p>
         </p:txBody>
@@ -7189,7 +7189,7 @@
                 </a:solidFill>
                 <a:latin typeface="Arial"/>
               </a:rPr>
-              <a:t>Azure Federal Control Compliance Automation · Date Code: 2026-07-12 15:00 ET</a:t>
+              <a:t>Azure Federal Control Compliance Automation · Date Code: 2026-07-28 08:45 ET</a:t>
             </a:r>
           </a:p>
         </p:txBody>
@@ -8183,7 +8183,7 @@
                 </a:solidFill>
                 <a:latin typeface="Arial"/>
               </a:rPr>
-              <a:t>Azure Federal Control Compliance Automation · Date Code: 2026-07-12 15:00 ET</a:t>
+              <a:t>Azure Federal Control Compliance Automation · Date Code: 2026-07-28 08:45 ET</a:t>
             </a:r>
           </a:p>
         </p:txBody>
@@ -9177,7 +9177,7 @@
                 </a:solidFill>
                 <a:latin typeface="Arial"/>
               </a:rPr>
-              <a:t>Azure Federal Control Compliance Automation · Date Code: 2026-07-12 15:00 ET</a:t>
+              <a:t>Azure Federal Control Compliance Automation · Date Code: 2026-07-28 08:45 ET</a:t>
             </a:r>
           </a:p>
         </p:txBody>
@@ -10171,7 +10171,7 @@
                 </a:solidFill>
                 <a:latin typeface="Arial"/>
               </a:rPr>
-              <a:t>Azure Federal Control Compliance Automation · Date Code: 2026-07-12 15:00 ET</a:t>
+              <a:t>Azure Federal Control Compliance Automation · Date Code: 2026-07-28 08:45 ET</a:t>
             </a:r>
           </a:p>
         </p:txBody>
@@ -10693,7 +10693,7 @@
                 </a:solidFill>
                 <a:latin typeface="Arial"/>
               </a:rPr>
-              <a:t>Azure Federal Control Compliance Automation · Date Code: 2026-07-12 15:00 ET</a:t>
+              <a:t>Azure Federal Control Compliance Automation · Date Code: 2026-07-28 08:45 ET</a:t>
             </a:r>
           </a:p>
         </p:txBody>

</xml_diff>